<commit_message>
API extensibility in Gardener
</commit_message>
<xml_diff>
--- a/kubernetes/11_3_morePods_Sheduling.pptx
+++ b/kubernetes/11_3_morePods_Sheduling.pptx
@@ -3471,340 +3471,116 @@
         </p:nvSpPr>
         <p:spPr/>
         <p:txBody>
-          <a:bodyPr>
-            <a:normAutofit lnSpcReduction="10000"/>
-          </a:bodyPr>
+          <a:bodyPr/>
           <a:lstStyle/>
           <a:p>
-            <a:pPr marL="285750" marR="0" lvl="0" indent="-285750" algn="l" defTabSz="1088776" rtl="0" eaLnBrk="1" fontAlgn="auto" latinLnBrk="0" hangingPunct="1">
-              <a:lnSpc>
-                <a:spcPct val="100000"/>
-              </a:lnSpc>
-              <a:spcBef>
-                <a:spcPts val="0"/>
-              </a:spcBef>
-              <a:spcAft>
-                <a:spcPts val="0"/>
-              </a:spcAft>
-              <a:buClrTx/>
-              <a:buSzTx/>
-              <a:buFontTx/>
-              <a:buChar char="-"/>
-              <a:tabLst/>
-              <a:defRPr/>
-            </a:pPr>
-            <a:r>
-              <a:rPr lang="en-US" baseline="0" dirty="0"/>
-              <a:t>Optionally you can show this demo</a:t>
-            </a:r>
-          </a:p>
-          <a:p>
-            <a:pPr marL="285750" marR="0" lvl="0" indent="-285750" algn="l" defTabSz="1088776" rtl="0" eaLnBrk="1" fontAlgn="auto" latinLnBrk="0" hangingPunct="1">
-              <a:lnSpc>
-                <a:spcPct val="100000"/>
-              </a:lnSpc>
-              <a:spcBef>
-                <a:spcPts val="0"/>
-              </a:spcBef>
-              <a:spcAft>
-                <a:spcPts val="0"/>
-              </a:spcAft>
-              <a:buClrTx/>
-              <a:buSzTx/>
-              <a:buFontTx/>
-              <a:buChar char="-"/>
-              <a:tabLst/>
-              <a:defRPr/>
-            </a:pPr>
-            <a:r>
-              <a:rPr lang="en-US" baseline="0" dirty="0"/>
-              <a:t>Firstly, try to create the custom resource object (09_cro.yaml). It will fail, as the cluster </a:t>
-            </a:r>
-            <a:r>
-              <a:rPr lang="en-US" baseline="0" dirty="0" err="1"/>
-              <a:t>api</a:t>
-            </a:r>
-            <a:r>
-              <a:rPr lang="en-US" baseline="0" dirty="0"/>
-              <a:t> doesn’t know about this resource type</a:t>
-            </a:r>
-          </a:p>
-          <a:p>
-            <a:pPr marL="285750" marR="0" lvl="0" indent="-285750" algn="l" defTabSz="1088776" rtl="0" eaLnBrk="1" fontAlgn="auto" latinLnBrk="0" hangingPunct="1">
-              <a:lnSpc>
-                <a:spcPct val="100000"/>
-              </a:lnSpc>
-              <a:spcBef>
-                <a:spcPts val="0"/>
-              </a:spcBef>
-              <a:spcAft>
-                <a:spcPts val="0"/>
-              </a:spcAft>
-              <a:buClrTx/>
-              <a:buSzTx/>
-              <a:buFontTx/>
-              <a:buChar char="-"/>
-              <a:tabLst/>
-              <a:defRPr/>
-            </a:pPr>
-            <a:r>
-              <a:rPr lang="en-US" baseline="0" dirty="0"/>
-              <a:t>Create the custom resource definition (09_crd.yaml). Show the </a:t>
-            </a:r>
-            <a:r>
-              <a:rPr lang="en-US" baseline="0" dirty="0" err="1"/>
-              <a:t>yaml</a:t>
-            </a:r>
-            <a:r>
-              <a:rPr lang="en-US" baseline="0" dirty="0"/>
-              <a:t> and explain the spec</a:t>
-            </a:r>
-          </a:p>
-          <a:p>
-            <a:pPr marL="465750" marR="0" lvl="1" indent="-285750" algn="l" defTabSz="1088776" rtl="0" eaLnBrk="1" fontAlgn="auto" latinLnBrk="0" hangingPunct="1">
-              <a:lnSpc>
-                <a:spcPct val="100000"/>
-              </a:lnSpc>
-              <a:spcBef>
-                <a:spcPts val="0"/>
-              </a:spcBef>
-              <a:spcAft>
-                <a:spcPts val="0"/>
-              </a:spcAft>
-              <a:buClrTx/>
-              <a:buSzTx/>
-              <a:buFontTx/>
-              <a:buChar char="-"/>
-              <a:tabLst/>
-              <a:defRPr/>
-            </a:pPr>
-            <a:r>
-              <a:rPr lang="en-US" baseline="0" dirty="0"/>
-              <a:t>Group: this is path in the </a:t>
-            </a:r>
-            <a:r>
-              <a:rPr lang="en-US" baseline="0" dirty="0" err="1"/>
-              <a:t>api</a:t>
-            </a:r>
-            <a:r>
-              <a:rPr lang="en-US" baseline="0" dirty="0"/>
-              <a:t> (like apps or apiextensions.k8s.io)</a:t>
-            </a:r>
-          </a:p>
-          <a:p>
-            <a:pPr marL="465750" marR="0" lvl="1" indent="-285750" algn="l" defTabSz="1088776" rtl="0" eaLnBrk="1" fontAlgn="auto" latinLnBrk="0" hangingPunct="1">
-              <a:lnSpc>
-                <a:spcPct val="100000"/>
-              </a:lnSpc>
-              <a:spcBef>
-                <a:spcPts val="0"/>
-              </a:spcBef>
-              <a:spcAft>
-                <a:spcPts val="0"/>
-              </a:spcAft>
-              <a:buClrTx/>
-              <a:buSzTx/>
-              <a:buFontTx/>
-              <a:buChar char="-"/>
-              <a:tabLst/>
-              <a:defRPr/>
-            </a:pPr>
-            <a:r>
-              <a:rPr lang="en-US" baseline="0" dirty="0"/>
-              <a:t>Version: version of the </a:t>
-            </a:r>
-            <a:r>
-              <a:rPr lang="en-US" baseline="0" dirty="0" err="1"/>
-              <a:t>api</a:t>
-            </a:r>
-            <a:r>
-              <a:rPr lang="en-US" baseline="0" dirty="0"/>
-              <a:t> objects in this group (like v1 or v1beta1)</a:t>
-            </a:r>
-          </a:p>
-          <a:p>
-            <a:pPr marL="465750" marR="0" lvl="1" indent="-285750" algn="l" defTabSz="1088776" rtl="0" eaLnBrk="1" fontAlgn="auto" latinLnBrk="0" hangingPunct="1">
-              <a:lnSpc>
-                <a:spcPct val="100000"/>
-              </a:lnSpc>
-              <a:spcBef>
-                <a:spcPts val="0"/>
-              </a:spcBef>
-              <a:spcAft>
-                <a:spcPts val="0"/>
-              </a:spcAft>
-              <a:buClrTx/>
-              <a:buSzTx/>
-              <a:buFontTx/>
-              <a:buChar char="-"/>
-              <a:tabLst/>
-              <a:defRPr/>
-            </a:pPr>
-            <a:r>
-              <a:rPr lang="en-US" baseline="0" dirty="0"/>
-              <a:t>Scope: objects can exist within a namespace like pods or outside like nodes</a:t>
-            </a:r>
-          </a:p>
-          <a:p>
-            <a:pPr marL="465750" marR="0" lvl="1" indent="-285750" algn="l" defTabSz="1088776" rtl="0" eaLnBrk="1" fontAlgn="auto" latinLnBrk="0" hangingPunct="1">
-              <a:lnSpc>
-                <a:spcPct val="100000"/>
-              </a:lnSpc>
-              <a:spcBef>
-                <a:spcPts val="0"/>
-              </a:spcBef>
-              <a:spcAft>
-                <a:spcPts val="0"/>
-              </a:spcAft>
-              <a:buClrTx/>
-              <a:buSzTx/>
-              <a:buFontTx/>
-              <a:buChar char="-"/>
-              <a:tabLst/>
-              <a:defRPr/>
-            </a:pPr>
-            <a:r>
-              <a:rPr lang="en-US" baseline="0" dirty="0"/>
-              <a:t>Names: names for the object, can also include a short version like </a:t>
-            </a:r>
-            <a:r>
-              <a:rPr lang="en-US" baseline="0" dirty="0" err="1"/>
-              <a:t>pvc</a:t>
-            </a:r>
-            <a:r>
-              <a:rPr lang="en-US" baseline="0" dirty="0"/>
-              <a:t> for </a:t>
-            </a:r>
-            <a:r>
-              <a:rPr lang="en-US" baseline="0" dirty="0" err="1"/>
-              <a:t>persistentvolumeclaim</a:t>
-            </a:r>
-            <a:endParaRPr lang="en-US" baseline="0" dirty="0"/>
-          </a:p>
-          <a:p>
-            <a:pPr marL="465750" marR="0" lvl="1" indent="-285750" algn="l" defTabSz="1088776" rtl="0" eaLnBrk="1" fontAlgn="auto" latinLnBrk="0" hangingPunct="1">
-              <a:lnSpc>
-                <a:spcPct val="100000"/>
-              </a:lnSpc>
-              <a:spcBef>
-                <a:spcPts val="0"/>
-              </a:spcBef>
-              <a:spcAft>
-                <a:spcPts val="0"/>
-              </a:spcAft>
-              <a:buClrTx/>
-              <a:buSzTx/>
-              <a:buFontTx/>
-              <a:buChar char="-"/>
-              <a:tabLst/>
-              <a:defRPr/>
-            </a:pPr>
-            <a:r>
-              <a:rPr lang="en-US" baseline="0" dirty="0"/>
-              <a:t>Validation: this is the definition of the objects structure and how to validate it. The example requires the training object with properties name and participants</a:t>
-            </a:r>
-          </a:p>
-          <a:p>
-            <a:pPr marL="465750" marR="0" lvl="1" indent="-285750" algn="l" defTabSz="1088776" rtl="0" eaLnBrk="1" fontAlgn="auto" latinLnBrk="0" hangingPunct="1">
-              <a:lnSpc>
-                <a:spcPct val="100000"/>
-              </a:lnSpc>
-              <a:spcBef>
-                <a:spcPts val="0"/>
-              </a:spcBef>
-              <a:spcAft>
-                <a:spcPts val="0"/>
-              </a:spcAft>
-              <a:buClrTx/>
-              <a:buSzTx/>
-              <a:buFontTx/>
-              <a:buChar char="-"/>
-              <a:tabLst/>
-              <a:defRPr/>
-            </a:pPr>
-            <a:endParaRPr lang="en-US" baseline="0" dirty="0"/>
-          </a:p>
-          <a:p>
-            <a:pPr marL="180000" marR="0" lvl="1" indent="0" algn="l" defTabSz="1088776" rtl="0" eaLnBrk="1" fontAlgn="auto" latinLnBrk="0" hangingPunct="1">
-              <a:lnSpc>
-                <a:spcPct val="100000"/>
-              </a:lnSpc>
-              <a:spcBef>
-                <a:spcPts val="0"/>
-              </a:spcBef>
-              <a:spcAft>
-                <a:spcPts val="0"/>
-              </a:spcAft>
-              <a:buClrTx/>
-              <a:buSzTx/>
-              <a:buFontTx/>
-              <a:buNone/>
-              <a:tabLst/>
-              <a:defRPr/>
-            </a:pPr>
-            <a:r>
-              <a:rPr lang="en-US" baseline="0" dirty="0"/>
-              <a:t>To move on one could write an operator, that could create namespaces based on course objects.</a:t>
-            </a:r>
-          </a:p>
-          <a:p>
-            <a:pPr marL="180000" marR="0" lvl="1" indent="0" algn="l" defTabSz="1088776" rtl="0" eaLnBrk="1" fontAlgn="auto" latinLnBrk="0" hangingPunct="1">
-              <a:lnSpc>
-                <a:spcPct val="100000"/>
-              </a:lnSpc>
-              <a:spcBef>
-                <a:spcPts val="0"/>
-              </a:spcBef>
-              <a:spcAft>
-                <a:spcPts val="0"/>
-              </a:spcAft>
-              <a:buClrTx/>
-              <a:buSzTx/>
-              <a:buFontTx/>
-              <a:buNone/>
-              <a:tabLst/>
-              <a:defRPr/>
-            </a:pPr>
-            <a:endParaRPr lang="en-US" baseline="0" dirty="0"/>
-          </a:p>
-          <a:p>
-            <a:pPr marL="180000" marR="0" lvl="1" indent="0" algn="l" defTabSz="1088776" rtl="0" eaLnBrk="1" fontAlgn="auto" latinLnBrk="0" hangingPunct="1">
-              <a:lnSpc>
-                <a:spcPct val="100000"/>
-              </a:lnSpc>
-              <a:spcBef>
-                <a:spcPts val="0"/>
-              </a:spcBef>
-              <a:spcAft>
-                <a:spcPts val="0"/>
-              </a:spcAft>
-              <a:buClrTx/>
-              <a:buSzTx/>
-              <a:buFontTx/>
-              <a:buNone/>
-              <a:tabLst/>
-              <a:defRPr/>
-            </a:pPr>
-            <a:r>
-              <a:rPr lang="en-US" baseline="0" dirty="0"/>
-              <a:t>A real life example is how Gardener manages the shoot clusters. When you create a new Gardener cluster, actually a </a:t>
-            </a:r>
-            <a:r>
-              <a:rPr lang="en-US" baseline="0" dirty="0" err="1"/>
-              <a:t>yaml</a:t>
-            </a:r>
-            <a:r>
-              <a:rPr lang="en-US" baseline="0" dirty="0"/>
-              <a:t> file is generated and send to the seed clusters </a:t>
-            </a:r>
-            <a:r>
-              <a:rPr lang="en-US" baseline="0" dirty="0" err="1"/>
-              <a:t>api</a:t>
-            </a:r>
-            <a:r>
-              <a:rPr lang="en-US" baseline="0" dirty="0"/>
-              <a:t> server. The operator evaluates it and triggers corresponding actions.</a:t>
-            </a:r>
+            <a:r>
+              <a:rPr lang="en-US" dirty="0" err="1"/>
+              <a:t>SteakfulSet</a:t>
+            </a:r>
+            <a:r>
+              <a:rPr lang="en-US"/>
+              <a:t> (pun </a:t>
+            </a:r>
+            <a:r>
+              <a:rPr lang="en-US" dirty="0"/>
+              <a:t>intended)</a:t>
+            </a:r>
+          </a:p>
+          <a:p>
+            <a:endParaRPr lang="en-US" dirty="0"/>
+          </a:p>
+          <a:p>
+            <a:r>
+              <a:rPr lang="en-US" dirty="0"/>
+              <a:t>The </a:t>
+            </a:r>
+            <a:r>
+              <a:rPr lang="en-US" dirty="0" err="1"/>
+              <a:t>SteakfulSet</a:t>
+            </a:r>
+            <a:r>
+              <a:rPr lang="en-US" dirty="0"/>
+              <a:t> is a custom resource and it is meant to show that custom resources can model almost anything, even food.</a:t>
+            </a:r>
+          </a:p>
+          <a:p>
+            <a:endParaRPr lang="en-US" dirty="0"/>
+          </a:p>
+          <a:p>
+            <a:r>
+              <a:rPr lang="en-US" dirty="0"/>
+              <a:t>The CRD on the left introduces the </a:t>
+            </a:r>
+            <a:r>
+              <a:rPr lang="en-US" dirty="0" err="1"/>
+              <a:t>SteakfulSet</a:t>
+            </a:r>
+            <a:r>
+              <a:rPr lang="en-US" dirty="0"/>
+              <a:t> resource to the cluster. I will be in the API ground </a:t>
+            </a:r>
+            <a:r>
+              <a:rPr lang="en-US" dirty="0" err="1"/>
+              <a:t>food.training.sap</a:t>
+            </a:r>
+            <a:r>
+              <a:rPr lang="en-US" dirty="0"/>
+              <a:t> with version v1. It can be referred to by its singular and plural names or by the short name </a:t>
+            </a:r>
+            <a:r>
+              <a:rPr lang="en-US" dirty="0" err="1"/>
+              <a:t>stks</a:t>
+            </a:r>
+            <a:r>
+              <a:rPr lang="en-US" dirty="0"/>
+              <a:t>.</a:t>
+            </a:r>
+          </a:p>
+          <a:p>
+            <a:endParaRPr lang="en-US" dirty="0"/>
+          </a:p>
+          <a:p>
+            <a:r>
+              <a:rPr lang="en-US" dirty="0"/>
+              <a:t>The openAPIV3Schema sets the structure of a </a:t>
+            </a:r>
+            <a:r>
+              <a:rPr lang="en-US" dirty="0" err="1"/>
+              <a:t>SteakfulSet</a:t>
+            </a:r>
+            <a:r>
+              <a:rPr lang="en-US" dirty="0"/>
+              <a:t> resource, i.e. which fields of which type it is made up of. The API server then will automatically validate the structure of any </a:t>
+            </a:r>
+            <a:r>
+              <a:rPr lang="en-US" dirty="0" err="1"/>
+              <a:t>SteakfulSet</a:t>
+            </a:r>
+            <a:r>
+              <a:rPr lang="en-US" dirty="0"/>
+              <a:t> resource created and reject it, if it does not comply with the given schema.</a:t>
+            </a:r>
+          </a:p>
+          <a:p>
+            <a:endParaRPr lang="en-US" dirty="0"/>
+          </a:p>
+          <a:p>
+            <a:r>
+              <a:rPr lang="en-US" dirty="0"/>
+              <a:t>Once this CRD is deployed to a cluster, it would actually accept </a:t>
+            </a:r>
+            <a:r>
+              <a:rPr lang="en-US" dirty="0" err="1"/>
+              <a:t>SteakfulSet</a:t>
+            </a:r>
+            <a:r>
+              <a:rPr lang="en-US" dirty="0"/>
+              <a:t> resources as given on the right.</a:t>
+            </a:r>
+          </a:p>
+          <a:p>
+            <a:endParaRPr lang="en-DE" dirty="0"/>
           </a:p>
         </p:txBody>
       </p:sp>
@@ -3815,7 +3591,7 @@
             <a:spLocks noGrp="1"/>
           </p:cNvSpPr>
           <p:nvPr>
-            <p:ph type="sldNum" sz="quarter" idx="10"/>
+            <p:ph type="sldNum" sz="quarter" idx="5"/>
           </p:nvPr>
         </p:nvSpPr>
         <p:spPr/>
@@ -3826,7 +3602,7 @@
             <a:fld id="{7D8C2C35-2B8A-446E-BEC0-FD36716C29AC}" type="slidenum">
               <a:rPr lang="de-DE" smtClean="0"/>
               <a:pPr/>
-              <a:t>14</a:t>
+              <a:t>13</a:t>
             </a:fld>
             <a:endParaRPr lang="de-DE" dirty="0"/>
           </a:p>
@@ -3835,7 +3611,7 @@
     </p:spTree>
     <p:extLst>
       <p:ext uri="{BB962C8B-B14F-4D97-AF65-F5344CB8AC3E}">
-        <p14:creationId xmlns:p14="http://schemas.microsoft.com/office/powerpoint/2010/main" val="549751525"/>
+        <p14:creationId xmlns:p14="http://schemas.microsoft.com/office/powerpoint/2010/main" val="1586761168"/>
       </p:ext>
     </p:extLst>
   </p:cSld>
@@ -3886,10 +3662,348 @@
         </p:nvSpPr>
         <p:spPr/>
         <p:txBody>
-          <a:bodyPr/>
+          <a:bodyPr>
+            <a:normAutofit lnSpcReduction="10000"/>
+          </a:bodyPr>
           <a:lstStyle/>
           <a:p>
-            <a:endParaRPr lang="en-US" dirty="0"/>
+            <a:pPr marL="285750" marR="0" lvl="0" indent="-285750" algn="l" defTabSz="1088776" rtl="0" eaLnBrk="1" fontAlgn="auto" latinLnBrk="0" hangingPunct="1">
+              <a:lnSpc>
+                <a:spcPct val="100000"/>
+              </a:lnSpc>
+              <a:spcBef>
+                <a:spcPts val="0"/>
+              </a:spcBef>
+              <a:spcAft>
+                <a:spcPts val="0"/>
+              </a:spcAft>
+              <a:buClrTx/>
+              <a:buSzTx/>
+              <a:buFontTx/>
+              <a:buChar char="-"/>
+              <a:tabLst/>
+              <a:defRPr/>
+            </a:pPr>
+            <a:r>
+              <a:rPr lang="en-US" baseline="0" dirty="0"/>
+              <a:t>Optionally you can show this demo</a:t>
+            </a:r>
+          </a:p>
+          <a:p>
+            <a:pPr marL="285750" marR="0" lvl="0" indent="-285750" algn="l" defTabSz="1088776" rtl="0" eaLnBrk="1" fontAlgn="auto" latinLnBrk="0" hangingPunct="1">
+              <a:lnSpc>
+                <a:spcPct val="100000"/>
+              </a:lnSpc>
+              <a:spcBef>
+                <a:spcPts val="0"/>
+              </a:spcBef>
+              <a:spcAft>
+                <a:spcPts val="0"/>
+              </a:spcAft>
+              <a:buClrTx/>
+              <a:buSzTx/>
+              <a:buFontTx/>
+              <a:buChar char="-"/>
+              <a:tabLst/>
+              <a:defRPr/>
+            </a:pPr>
+            <a:r>
+              <a:rPr lang="en-US" baseline="0" dirty="0"/>
+              <a:t>Firstly, try to create the custom resource object (09_cro.yaml). It will fail, as the cluster </a:t>
+            </a:r>
+            <a:r>
+              <a:rPr lang="en-US" baseline="0" dirty="0" err="1"/>
+              <a:t>api</a:t>
+            </a:r>
+            <a:r>
+              <a:rPr lang="en-US" baseline="0" dirty="0"/>
+              <a:t> doesn’t know about this resource type</a:t>
+            </a:r>
+          </a:p>
+          <a:p>
+            <a:pPr marL="285750" marR="0" lvl="0" indent="-285750" algn="l" defTabSz="1088776" rtl="0" eaLnBrk="1" fontAlgn="auto" latinLnBrk="0" hangingPunct="1">
+              <a:lnSpc>
+                <a:spcPct val="100000"/>
+              </a:lnSpc>
+              <a:spcBef>
+                <a:spcPts val="0"/>
+              </a:spcBef>
+              <a:spcAft>
+                <a:spcPts val="0"/>
+              </a:spcAft>
+              <a:buClrTx/>
+              <a:buSzTx/>
+              <a:buFontTx/>
+              <a:buChar char="-"/>
+              <a:tabLst/>
+              <a:defRPr/>
+            </a:pPr>
+            <a:r>
+              <a:rPr lang="en-US" baseline="0" dirty="0"/>
+              <a:t>Create the custom resource definition (09_crd.yaml). Show the </a:t>
+            </a:r>
+            <a:r>
+              <a:rPr lang="en-US" baseline="0" dirty="0" err="1"/>
+              <a:t>yaml</a:t>
+            </a:r>
+            <a:r>
+              <a:rPr lang="en-US" baseline="0" dirty="0"/>
+              <a:t> and explain the spec</a:t>
+            </a:r>
+          </a:p>
+          <a:p>
+            <a:pPr marL="465750" marR="0" lvl="1" indent="-285750" algn="l" defTabSz="1088776" rtl="0" eaLnBrk="1" fontAlgn="auto" latinLnBrk="0" hangingPunct="1">
+              <a:lnSpc>
+                <a:spcPct val="100000"/>
+              </a:lnSpc>
+              <a:spcBef>
+                <a:spcPts val="0"/>
+              </a:spcBef>
+              <a:spcAft>
+                <a:spcPts val="0"/>
+              </a:spcAft>
+              <a:buClrTx/>
+              <a:buSzTx/>
+              <a:buFontTx/>
+              <a:buChar char="-"/>
+              <a:tabLst/>
+              <a:defRPr/>
+            </a:pPr>
+            <a:r>
+              <a:rPr lang="en-US" baseline="0" dirty="0"/>
+              <a:t>Group: this is path in the </a:t>
+            </a:r>
+            <a:r>
+              <a:rPr lang="en-US" baseline="0" dirty="0" err="1"/>
+              <a:t>api</a:t>
+            </a:r>
+            <a:r>
+              <a:rPr lang="en-US" baseline="0" dirty="0"/>
+              <a:t> (like apps or apiextensions.k8s.io)</a:t>
+            </a:r>
+          </a:p>
+          <a:p>
+            <a:pPr marL="465750" marR="0" lvl="1" indent="-285750" algn="l" defTabSz="1088776" rtl="0" eaLnBrk="1" fontAlgn="auto" latinLnBrk="0" hangingPunct="1">
+              <a:lnSpc>
+                <a:spcPct val="100000"/>
+              </a:lnSpc>
+              <a:spcBef>
+                <a:spcPts val="0"/>
+              </a:spcBef>
+              <a:spcAft>
+                <a:spcPts val="0"/>
+              </a:spcAft>
+              <a:buClrTx/>
+              <a:buSzTx/>
+              <a:buFontTx/>
+              <a:buChar char="-"/>
+              <a:tabLst/>
+              <a:defRPr/>
+            </a:pPr>
+            <a:r>
+              <a:rPr lang="en-US" baseline="0" dirty="0"/>
+              <a:t>Version: version of the </a:t>
+            </a:r>
+            <a:r>
+              <a:rPr lang="en-US" baseline="0" dirty="0" err="1"/>
+              <a:t>api</a:t>
+            </a:r>
+            <a:r>
+              <a:rPr lang="en-US" baseline="0" dirty="0"/>
+              <a:t> objects in this group (like v1 or v1beta1)</a:t>
+            </a:r>
+          </a:p>
+          <a:p>
+            <a:pPr marL="465750" marR="0" lvl="1" indent="-285750" algn="l" defTabSz="1088776" rtl="0" eaLnBrk="1" fontAlgn="auto" latinLnBrk="0" hangingPunct="1">
+              <a:lnSpc>
+                <a:spcPct val="100000"/>
+              </a:lnSpc>
+              <a:spcBef>
+                <a:spcPts val="0"/>
+              </a:spcBef>
+              <a:spcAft>
+                <a:spcPts val="0"/>
+              </a:spcAft>
+              <a:buClrTx/>
+              <a:buSzTx/>
+              <a:buFontTx/>
+              <a:buChar char="-"/>
+              <a:tabLst/>
+              <a:defRPr/>
+            </a:pPr>
+            <a:r>
+              <a:rPr lang="en-US" baseline="0" dirty="0"/>
+              <a:t>Scope: objects can exist within a namespace like pods or outside like nodes</a:t>
+            </a:r>
+          </a:p>
+          <a:p>
+            <a:pPr marL="465750" marR="0" lvl="1" indent="-285750" algn="l" defTabSz="1088776" rtl="0" eaLnBrk="1" fontAlgn="auto" latinLnBrk="0" hangingPunct="1">
+              <a:lnSpc>
+                <a:spcPct val="100000"/>
+              </a:lnSpc>
+              <a:spcBef>
+                <a:spcPts val="0"/>
+              </a:spcBef>
+              <a:spcAft>
+                <a:spcPts val="0"/>
+              </a:spcAft>
+              <a:buClrTx/>
+              <a:buSzTx/>
+              <a:buFontTx/>
+              <a:buChar char="-"/>
+              <a:tabLst/>
+              <a:defRPr/>
+            </a:pPr>
+            <a:r>
+              <a:rPr lang="en-US" baseline="0" dirty="0"/>
+              <a:t>Names: names for the object, can also include a short version like </a:t>
+            </a:r>
+            <a:r>
+              <a:rPr lang="en-US" baseline="0" dirty="0" err="1"/>
+              <a:t>pvc</a:t>
+            </a:r>
+            <a:r>
+              <a:rPr lang="en-US" baseline="0" dirty="0"/>
+              <a:t> for </a:t>
+            </a:r>
+            <a:r>
+              <a:rPr lang="en-US" baseline="0" dirty="0" err="1"/>
+              <a:t>persistentvolumeclaim</a:t>
+            </a:r>
+            <a:endParaRPr lang="en-US" baseline="0" dirty="0"/>
+          </a:p>
+          <a:p>
+            <a:pPr marL="465750" marR="0" lvl="1" indent="-285750" algn="l" defTabSz="1088776" rtl="0" eaLnBrk="1" fontAlgn="auto" latinLnBrk="0" hangingPunct="1">
+              <a:lnSpc>
+                <a:spcPct val="100000"/>
+              </a:lnSpc>
+              <a:spcBef>
+                <a:spcPts val="0"/>
+              </a:spcBef>
+              <a:spcAft>
+                <a:spcPts val="0"/>
+              </a:spcAft>
+              <a:buClrTx/>
+              <a:buSzTx/>
+              <a:buFontTx/>
+              <a:buChar char="-"/>
+              <a:tabLst/>
+              <a:defRPr/>
+            </a:pPr>
+            <a:r>
+              <a:rPr lang="en-US" baseline="0" dirty="0"/>
+              <a:t>Validation: this is the definition of the objects structure and how to validate it. The example requires the training object with properties name and participants</a:t>
+            </a:r>
+          </a:p>
+          <a:p>
+            <a:pPr marL="465750" marR="0" lvl="1" indent="-285750" algn="l" defTabSz="1088776" rtl="0" eaLnBrk="1" fontAlgn="auto" latinLnBrk="0" hangingPunct="1">
+              <a:lnSpc>
+                <a:spcPct val="100000"/>
+              </a:lnSpc>
+              <a:spcBef>
+                <a:spcPts val="0"/>
+              </a:spcBef>
+              <a:spcAft>
+                <a:spcPts val="0"/>
+              </a:spcAft>
+              <a:buClrTx/>
+              <a:buSzTx/>
+              <a:buFontTx/>
+              <a:buChar char="-"/>
+              <a:tabLst/>
+              <a:defRPr/>
+            </a:pPr>
+            <a:endParaRPr lang="en-US" baseline="0" dirty="0"/>
+          </a:p>
+          <a:p>
+            <a:pPr marL="180000" marR="0" lvl="1" indent="0" algn="l" defTabSz="1088776" rtl="0" eaLnBrk="1" fontAlgn="auto" latinLnBrk="0" hangingPunct="1">
+              <a:lnSpc>
+                <a:spcPct val="100000"/>
+              </a:lnSpc>
+              <a:spcBef>
+                <a:spcPts val="0"/>
+              </a:spcBef>
+              <a:spcAft>
+                <a:spcPts val="0"/>
+              </a:spcAft>
+              <a:buClrTx/>
+              <a:buSzTx/>
+              <a:buFontTx/>
+              <a:buNone/>
+              <a:tabLst/>
+              <a:defRPr/>
+            </a:pPr>
+            <a:r>
+              <a:rPr lang="en-US" baseline="0" dirty="0"/>
+              <a:t>To move on one could write an operator – for the </a:t>
+            </a:r>
+            <a:r>
+              <a:rPr lang="en-US" baseline="0" dirty="0" err="1"/>
+              <a:t>SteakfulSet</a:t>
+            </a:r>
+            <a:r>
+              <a:rPr lang="en-US" baseline="0" dirty="0"/>
+              <a:t>, there actually is a simple (demo-) implementation of an operator at https://github.wdf.sap.corp/slvi/crd-controller-demo.</a:t>
+            </a:r>
+          </a:p>
+          <a:p>
+            <a:pPr marL="180000" marR="0" lvl="1" indent="0" algn="l" defTabSz="1088776" rtl="0" eaLnBrk="1" fontAlgn="auto" latinLnBrk="0" hangingPunct="1">
+              <a:lnSpc>
+                <a:spcPct val="100000"/>
+              </a:lnSpc>
+              <a:spcBef>
+                <a:spcPts val="0"/>
+              </a:spcBef>
+              <a:spcAft>
+                <a:spcPts val="0"/>
+              </a:spcAft>
+              <a:buClrTx/>
+              <a:buSzTx/>
+              <a:buFontTx/>
+              <a:buNone/>
+              <a:tabLst/>
+              <a:defRPr/>
+            </a:pPr>
+            <a:endParaRPr lang="en-US" baseline="0" dirty="0"/>
+          </a:p>
+          <a:p>
+            <a:pPr marL="180000" marR="0" lvl="1" indent="0" algn="l" defTabSz="1088776" rtl="0" eaLnBrk="1" fontAlgn="auto" latinLnBrk="0" hangingPunct="1">
+              <a:lnSpc>
+                <a:spcPct val="100000"/>
+              </a:lnSpc>
+              <a:spcBef>
+                <a:spcPts val="0"/>
+              </a:spcBef>
+              <a:spcAft>
+                <a:spcPts val="0"/>
+              </a:spcAft>
+              <a:buClrTx/>
+              <a:buSzTx/>
+              <a:buFontTx/>
+              <a:buNone/>
+              <a:tabLst/>
+              <a:defRPr/>
+            </a:pPr>
+            <a:r>
+              <a:rPr lang="en-US" baseline="0" dirty="0"/>
+              <a:t>A real life example is how Gardener manages the shoot clusters. When you create a new Gardener cluster, actually a </a:t>
+            </a:r>
+            <a:r>
+              <a:rPr lang="en-US" baseline="0" dirty="0" err="1"/>
+              <a:t>yaml</a:t>
+            </a:r>
+            <a:r>
+              <a:rPr lang="en-US" baseline="0" dirty="0"/>
+              <a:t> file is generated and send to the seed clusters </a:t>
+            </a:r>
+            <a:r>
+              <a:rPr lang="en-US" baseline="0" dirty="0" err="1"/>
+              <a:t>api</a:t>
+            </a:r>
+            <a:r>
+              <a:rPr lang="en-US" baseline="0" dirty="0"/>
+              <a:t> server. The operator evaluates it and triggers corresponding actions.</a:t>
+            </a:r>
           </a:p>
         </p:txBody>
       </p:sp>
@@ -3909,18 +4023,18 @@
           <a:lstStyle/>
           <a:p>
             <a:fld id="{7D8C2C35-2B8A-446E-BEC0-FD36716C29AC}" type="slidenum">
-              <a:rPr lang="en-US" smtClean="0"/>
+              <a:rPr lang="de-DE" smtClean="0"/>
               <a:pPr/>
-              <a:t>15</a:t>
+              <a:t>14</a:t>
             </a:fld>
-            <a:endParaRPr lang="en-US" dirty="0"/>
+            <a:endParaRPr lang="de-DE" dirty="0"/>
           </a:p>
         </p:txBody>
       </p:sp>
     </p:spTree>
     <p:extLst>
       <p:ext uri="{BB962C8B-B14F-4D97-AF65-F5344CB8AC3E}">
-        <p14:creationId xmlns:p14="http://schemas.microsoft.com/office/powerpoint/2010/main" val="1582342442"/>
+        <p14:creationId xmlns:p14="http://schemas.microsoft.com/office/powerpoint/2010/main" val="549751525"/>
       </p:ext>
     </p:extLst>
   </p:cSld>
@@ -3994,18 +4108,18 @@
           <a:lstStyle/>
           <a:p>
             <a:fld id="{7D8C2C35-2B8A-446E-BEC0-FD36716C29AC}" type="slidenum">
-              <a:rPr lang="de-DE" smtClean="0"/>
+              <a:rPr lang="en-US" smtClean="0"/>
               <a:pPr/>
-              <a:t>16</a:t>
+              <a:t>15</a:t>
             </a:fld>
-            <a:endParaRPr lang="de-DE" dirty="0"/>
+            <a:endParaRPr lang="en-US" dirty="0"/>
           </a:p>
         </p:txBody>
       </p:sp>
     </p:spTree>
     <p:extLst>
       <p:ext uri="{BB962C8B-B14F-4D97-AF65-F5344CB8AC3E}">
-        <p14:creationId xmlns:p14="http://schemas.microsoft.com/office/powerpoint/2010/main" val="3466716593"/>
+        <p14:creationId xmlns:p14="http://schemas.microsoft.com/office/powerpoint/2010/main" val="1582342442"/>
       </p:ext>
     </p:extLst>
   </p:cSld>
@@ -4081,7 +4195,7 @@
             <a:fld id="{7D8C2C35-2B8A-446E-BEC0-FD36716C29AC}" type="slidenum">
               <a:rPr lang="de-DE" smtClean="0"/>
               <a:pPr/>
-              <a:t>17</a:t>
+              <a:t>16</a:t>
             </a:fld>
             <a:endParaRPr lang="de-DE" dirty="0"/>
           </a:p>
@@ -4090,7 +4204,7 @@
     </p:spTree>
     <p:extLst>
       <p:ext uri="{BB962C8B-B14F-4D97-AF65-F5344CB8AC3E}">
-        <p14:creationId xmlns:p14="http://schemas.microsoft.com/office/powerpoint/2010/main" val="157809321"/>
+        <p14:creationId xmlns:p14="http://schemas.microsoft.com/office/powerpoint/2010/main" val="3466716593"/>
       </p:ext>
     </p:extLst>
   </p:cSld>
@@ -4141,70 +4255,9 @@
         </p:nvSpPr>
         <p:spPr/>
         <p:txBody>
-          <a:bodyPr>
-            <a:normAutofit/>
-          </a:bodyPr>
+          <a:bodyPr/>
           <a:lstStyle/>
           <a:p>
-            <a:r>
-              <a:rPr lang="en-US" baseline="0" dirty="0"/>
-              <a:t>Optional demo: </a:t>
-            </a:r>
-          </a:p>
-          <a:p>
-            <a:r>
-              <a:rPr lang="en-US" baseline="0" dirty="0"/>
-              <a:t>To access the cluster’s dashboard, use the Gardener UI or port-forward the to dashboard pod (example: </a:t>
-            </a:r>
-            <a:r>
-              <a:rPr lang="en-US" baseline="0" dirty="0" err="1"/>
-              <a:t>kubectl</a:t>
-            </a:r>
-            <a:r>
-              <a:rPr lang="en-US" baseline="0" dirty="0"/>
-              <a:t> port-forward -n </a:t>
-            </a:r>
-            <a:r>
-              <a:rPr lang="en-US" baseline="0" dirty="0" err="1"/>
-              <a:t>kube</a:t>
-            </a:r>
-            <a:r>
-              <a:rPr lang="en-US" baseline="0" dirty="0"/>
-              <a:t>-system addons-kubernetes-dashboard-5486b968b7-zf62b 8443:8443)</a:t>
-            </a:r>
-          </a:p>
-          <a:p>
-            <a:endParaRPr lang="en-US" baseline="0" dirty="0"/>
-          </a:p>
-          <a:p>
-            <a:r>
-              <a:rPr lang="en-US" baseline="0" dirty="0"/>
-              <a:t>Demo the dashboard</a:t>
-            </a:r>
-          </a:p>
-          <a:p>
-            <a:r>
-              <a:rPr lang="en-US" baseline="0" dirty="0"/>
-              <a:t>- Show status info &amp; utilization of nodes</a:t>
-            </a:r>
-          </a:p>
-          <a:p>
-            <a:r>
-              <a:rPr lang="en-US" dirty="0"/>
-              <a:t>- Show deployments</a:t>
-            </a:r>
-            <a:r>
-              <a:rPr lang="en-US" baseline="0" dirty="0"/>
-              <a:t> </a:t>
-            </a:r>
-            <a:r>
-              <a:rPr lang="en-US" dirty="0"/>
-              <a:t>&amp; services and how to create a new</a:t>
-            </a:r>
-            <a:r>
-              <a:rPr lang="en-US" baseline="0" dirty="0"/>
-              <a:t> deployment</a:t>
-            </a:r>
             <a:endParaRPr lang="en-US" dirty="0"/>
           </a:p>
         </p:txBody>
@@ -4227,6 +4280,152 @@
             <a:fld id="{7D8C2C35-2B8A-446E-BEC0-FD36716C29AC}" type="slidenum">
               <a:rPr lang="de-DE" smtClean="0"/>
               <a:pPr/>
+              <a:t>17</a:t>
+            </a:fld>
+            <a:endParaRPr lang="de-DE" dirty="0"/>
+          </a:p>
+        </p:txBody>
+      </p:sp>
+    </p:spTree>
+    <p:extLst>
+      <p:ext uri="{BB962C8B-B14F-4D97-AF65-F5344CB8AC3E}">
+        <p14:creationId xmlns:p14="http://schemas.microsoft.com/office/powerpoint/2010/main" val="157809321"/>
+      </p:ext>
+    </p:extLst>
+  </p:cSld>
+  <p:clrMapOvr>
+    <a:masterClrMapping/>
+  </p:clrMapOvr>
+</p:notes>
+</file>
+
+<file path=ppt/notesSlides/notesSlide16.xml><?xml version="1.0" encoding="utf-8"?>
+<p:notes xmlns:a="http://schemas.openxmlformats.org/drawingml/2006/main" xmlns:r="http://schemas.openxmlformats.org/officeDocument/2006/relationships" xmlns:p="http://schemas.openxmlformats.org/presentationml/2006/main">
+  <p:cSld>
+    <p:spTree>
+      <p:nvGrpSpPr>
+        <p:cNvPr id="1" name=""/>
+        <p:cNvGrpSpPr/>
+        <p:nvPr/>
+      </p:nvGrpSpPr>
+      <p:grpSpPr>
+        <a:xfrm>
+          <a:off x="0" y="0"/>
+          <a:ext cx="0" cy="0"/>
+          <a:chOff x="0" y="0"/>
+          <a:chExt cx="0" cy="0"/>
+        </a:xfrm>
+      </p:grpSpPr>
+      <p:sp>
+        <p:nvSpPr>
+          <p:cNvPr id="2" name="Slide Image Placeholder 1"/>
+          <p:cNvSpPr>
+            <a:spLocks noGrp="1" noRot="1" noChangeAspect="1"/>
+          </p:cNvSpPr>
+          <p:nvPr>
+            <p:ph type="sldImg"/>
+          </p:nvPr>
+        </p:nvSpPr>
+        <p:spPr/>
+      </p:sp>
+      <p:sp>
+        <p:nvSpPr>
+          <p:cNvPr id="3" name="Notes Placeholder 2"/>
+          <p:cNvSpPr>
+            <a:spLocks noGrp="1"/>
+          </p:cNvSpPr>
+          <p:nvPr>
+            <p:ph type="body" idx="1"/>
+          </p:nvPr>
+        </p:nvSpPr>
+        <p:spPr/>
+        <p:txBody>
+          <a:bodyPr>
+            <a:normAutofit/>
+          </a:bodyPr>
+          <a:lstStyle/>
+          <a:p>
+            <a:r>
+              <a:rPr lang="en-US" baseline="0" dirty="0"/>
+              <a:t>Optional demo: </a:t>
+            </a:r>
+          </a:p>
+          <a:p>
+            <a:r>
+              <a:rPr lang="en-US" baseline="0" dirty="0"/>
+              <a:t>To access the cluster’s dashboard, use the Gardener UI or port-forward the to dashboard pod (example: </a:t>
+            </a:r>
+            <a:r>
+              <a:rPr lang="en-US" baseline="0" dirty="0" err="1"/>
+              <a:t>kubectl</a:t>
+            </a:r>
+            <a:r>
+              <a:rPr lang="en-US" baseline="0" dirty="0"/>
+              <a:t> port-forward -n </a:t>
+            </a:r>
+            <a:r>
+              <a:rPr lang="en-US" baseline="0" dirty="0" err="1"/>
+              <a:t>kube</a:t>
+            </a:r>
+            <a:r>
+              <a:rPr lang="en-US" baseline="0" dirty="0"/>
+              <a:t>-system addons-kubernetes-dashboard-5486b968b7-zf62b 8443:8443)</a:t>
+            </a:r>
+          </a:p>
+          <a:p>
+            <a:endParaRPr lang="en-US" baseline="0" dirty="0"/>
+          </a:p>
+          <a:p>
+            <a:r>
+              <a:rPr lang="en-US" baseline="0" dirty="0"/>
+              <a:t>Demo the dashboard</a:t>
+            </a:r>
+          </a:p>
+          <a:p>
+            <a:r>
+              <a:rPr lang="en-US" baseline="0" dirty="0"/>
+              <a:t>- Show status info &amp; utilization of nodes</a:t>
+            </a:r>
+          </a:p>
+          <a:p>
+            <a:r>
+              <a:rPr lang="en-US" dirty="0"/>
+              <a:t>- Show deployments</a:t>
+            </a:r>
+            <a:r>
+              <a:rPr lang="en-US" baseline="0" dirty="0"/>
+              <a:t> </a:t>
+            </a:r>
+            <a:r>
+              <a:rPr lang="en-US" dirty="0"/>
+              <a:t>&amp; services and how to create a new</a:t>
+            </a:r>
+            <a:r>
+              <a:rPr lang="en-US" baseline="0" dirty="0"/>
+              <a:t> deployment</a:t>
+            </a:r>
+            <a:endParaRPr lang="en-US" dirty="0"/>
+          </a:p>
+        </p:txBody>
+      </p:sp>
+      <p:sp>
+        <p:nvSpPr>
+          <p:cNvPr id="4" name="Slide Number Placeholder 3"/>
+          <p:cNvSpPr>
+            <a:spLocks noGrp="1"/>
+          </p:cNvSpPr>
+          <p:nvPr>
+            <p:ph type="sldNum" sz="quarter" idx="10"/>
+          </p:nvPr>
+        </p:nvSpPr>
+        <p:spPr/>
+        <p:txBody>
+          <a:bodyPr/>
+          <a:lstStyle/>
+          <a:p>
+            <a:fld id="{7D8C2C35-2B8A-446E-BEC0-FD36716C29AC}" type="slidenum">
+              <a:rPr lang="de-DE" smtClean="0"/>
+              <a:pPr/>
               <a:t>18</a:t>
             </a:fld>
             <a:endParaRPr lang="de-DE" dirty="0"/>
@@ -4246,7 +4445,7 @@
 </p:notes>
 </file>
 
-<file path=ppt/notesSlides/notesSlide16.xml><?xml version="1.0" encoding="utf-8"?>
+<file path=ppt/notesSlides/notesSlide17.xml><?xml version="1.0" encoding="utf-8"?>
 <p:notes xmlns:a="http://schemas.openxmlformats.org/drawingml/2006/main" xmlns:r="http://schemas.openxmlformats.org/officeDocument/2006/relationships" xmlns:p="http://schemas.openxmlformats.org/presentationml/2006/main">
   <p:cSld>
     <p:spTree>
@@ -20543,45 +20742,10 @@
       </p:grpSpPr>
       <p:pic>
         <p:nvPicPr>
-          <p:cNvPr id="2" name="Picture 1">
+          <p:cNvPr id="5" name="Picture 4">
             <a:extLst>
               <a:ext uri="{FF2B5EF4-FFF2-40B4-BE49-F238E27FC236}">
-                <a16:creationId xmlns:a16="http://schemas.microsoft.com/office/drawing/2014/main" id="{5628F058-60DD-4407-8BAB-257B7CBA7802}"/>
-              </a:ext>
-            </a:extLst>
-          </p:cNvPr>
-          <p:cNvPicPr>
-            <a:picLocks noChangeAspect="1"/>
-          </p:cNvPicPr>
-          <p:nvPr/>
-        </p:nvPicPr>
-        <p:blipFill>
-          <a:blip r:embed="rId2"/>
-          <a:stretch>
-            <a:fillRect/>
-          </a:stretch>
-        </p:blipFill>
-        <p:spPr>
-          <a:xfrm>
-            <a:off x="504001" y="969917"/>
-            <a:ext cx="3237980" cy="5560879"/>
-          </a:xfrm>
-          <a:prstGeom prst="rect">
-            <a:avLst/>
-          </a:prstGeom>
-          <a:ln>
-            <a:solidFill>
-              <a:schemeClr val="tx1"/>
-            </a:solidFill>
-          </a:ln>
-        </p:spPr>
-      </p:pic>
-      <p:pic>
-        <p:nvPicPr>
-          <p:cNvPr id="10" name="Picture 9">
-            <a:extLst>
-              <a:ext uri="{FF2B5EF4-FFF2-40B4-BE49-F238E27FC236}">
-                <a16:creationId xmlns:a16="http://schemas.microsoft.com/office/drawing/2014/main" id="{93F5C68F-E879-4B51-9EAF-54BF7B5C7048}"/>
+                <a16:creationId xmlns:a16="http://schemas.microsoft.com/office/drawing/2014/main" id="{51E8D585-6C05-4761-868E-D358D943005F}"/>
               </a:ext>
             </a:extLst>
           </p:cNvPr>
@@ -20598,8 +20762,43 @@
         </p:blipFill>
         <p:spPr>
           <a:xfrm>
-            <a:off x="7952510" y="2196225"/>
-            <a:ext cx="3146480" cy="2278485"/>
+            <a:off x="8013146" y="2097620"/>
+            <a:ext cx="3255453" cy="2592524"/>
+          </a:xfrm>
+          <a:prstGeom prst="rect">
+            <a:avLst/>
+          </a:prstGeom>
+          <a:ln>
+            <a:solidFill>
+              <a:schemeClr val="tx1"/>
+            </a:solidFill>
+          </a:ln>
+        </p:spPr>
+      </p:pic>
+      <p:pic>
+        <p:nvPicPr>
+          <p:cNvPr id="4" name="Picture 3">
+            <a:extLst>
+              <a:ext uri="{FF2B5EF4-FFF2-40B4-BE49-F238E27FC236}">
+                <a16:creationId xmlns:a16="http://schemas.microsoft.com/office/drawing/2014/main" id="{B1476AAD-DB08-4C86-B947-EBA4B95AEBE1}"/>
+              </a:ext>
+            </a:extLst>
+          </p:cNvPr>
+          <p:cNvPicPr>
+            <a:picLocks noChangeAspect="1"/>
+          </p:cNvPicPr>
+          <p:nvPr/>
+        </p:nvPicPr>
+        <p:blipFill>
+          <a:blip r:embed="rId4"/>
+          <a:stretch>
+            <a:fillRect/>
+          </a:stretch>
+        </p:blipFill>
+        <p:spPr>
+          <a:xfrm>
+            <a:off x="632628" y="873332"/>
+            <a:ext cx="3118088" cy="5616494"/>
           </a:xfrm>
           <a:prstGeom prst="rect">
             <a:avLst/>
@@ -20658,8 +20857,8 @@
           </a:xfrm>
           <a:prstGeom prst="wedgeRectCallout">
             <a:avLst>
-              <a:gd name="adj1" fmla="val -73263"/>
-              <a:gd name="adj2" fmla="val 64322"/>
+              <a:gd name="adj1" fmla="val -83392"/>
+              <a:gd name="adj2" fmla="val 55818"/>
             </a:avLst>
           </a:prstGeom>
           <a:ln>
@@ -20735,13 +20934,13 @@
         </p:nvSpPr>
         <p:spPr bwMode="gray">
           <a:xfrm>
-            <a:off x="3558691" y="2920579"/>
+            <a:off x="3838189" y="3266690"/>
             <a:ext cx="3067662" cy="829778"/>
           </a:xfrm>
           <a:prstGeom prst="wedgeRectCallout">
             <a:avLst>
-              <a:gd name="adj1" fmla="val -73263"/>
-              <a:gd name="adj2" fmla="val 64322"/>
+              <a:gd name="adj1" fmla="val -89758"/>
+              <a:gd name="adj2" fmla="val 118886"/>
             </a:avLst>
           </a:prstGeom>
           <a:ln>
@@ -20817,13 +21016,13 @@
         </p:nvSpPr>
         <p:spPr bwMode="gray">
           <a:xfrm>
-            <a:off x="4654296" y="4988132"/>
+            <a:off x="7727622" y="5301770"/>
             <a:ext cx="3393646" cy="829778"/>
           </a:xfrm>
           <a:prstGeom prst="wedgeRectCallout">
             <a:avLst>
-              <a:gd name="adj1" fmla="val 58487"/>
-              <a:gd name="adj2" fmla="val -108688"/>
+              <a:gd name="adj1" fmla="val 3290"/>
+              <a:gd name="adj2" fmla="val -143995"/>
             </a:avLst>
           </a:prstGeom>
           <a:ln>
@@ -20899,13 +21098,13 @@
         </p:nvSpPr>
         <p:spPr bwMode="gray">
           <a:xfrm>
-            <a:off x="7705344" y="1056781"/>
+            <a:off x="8168901" y="726452"/>
             <a:ext cx="3393646" cy="591749"/>
           </a:xfrm>
           <a:prstGeom prst="wedgeRectCallout">
             <a:avLst>
-              <a:gd name="adj1" fmla="val 32351"/>
-              <a:gd name="adj2" fmla="val 135952"/>
+              <a:gd name="adj1" fmla="val -4272"/>
+              <a:gd name="adj2" fmla="val 186960"/>
             </a:avLst>
           </a:prstGeom>
           <a:ln>

</xml_diff>